<commit_message>
update all slide decks
</commit_message>
<xml_diff>
--- a/MECH191_metallurgy/slideDecks/pptx/MECH191_Week10_Lecture.pptx
+++ b/MECH191_metallurgy/slideDecks/pptx/MECH191_Week10_Lecture.pptx
@@ -16158,7 +16158,7 @@
         </p:spPr>
         <p:txBody>
           <a:bodyPr wrap="none" lIns="0" rIns="0" tIns="0" bIns="0">
-            <a:spAutoFit/>
+            <a:noAutofit/>
           </a:bodyPr>
           <a:lstStyle/>
           <a:p>
@@ -16169,7 +16169,7 @@
                 </a:solidFill>
                 <a:latin typeface="Calibri"/>
               </a:rPr>
-              <a:t>Metallography Lab — Module 9</a:t>
+              <a:t>Alloy Research Portfolio — Module 9</a:t>
             </a:r>
           </a:p>
         </p:txBody>
@@ -16192,7 +16192,7 @@
         </p:spPr>
         <p:txBody>
           <a:bodyPr wrap="none" lIns="0" rIns="0" tIns="0" bIns="0">
-            <a:spAutoFit/>
+            <a:noAutofit/>
           </a:bodyPr>
           <a:lstStyle/>
           <a:p>
@@ -16203,7 +16203,7 @@
                 </a:solidFill>
                 <a:latin typeface="Calibri"/>
               </a:rPr>
-              <a:t>EXAMET-5-R-600-HD  ·  50–500×</a:t>
+              <a:t>No Microscope Required</a:t>
             </a:r>
           </a:p>
         </p:txBody>
@@ -16328,7 +16328,7 @@
         </p:spPr>
         <p:txBody>
           <a:bodyPr wrap="none" lIns="0" rIns="0" tIns="0" bIns="0">
-            <a:spAutoFit/>
+            <a:noAutofit/>
           </a:bodyPr>
           <a:lstStyle/>
           <a:p>
@@ -16339,7 +16339,7 @@
                 </a:solidFill>
                 <a:latin typeface="Calibri"/>
               </a:rPr>
-              <a:t>Compare constituent particle size/density between 6061-T6 and 2024-T3 at </a:t>
+              <a:t>Research 6061-T6 vs. 2024-T3 aluminum: constituent particles and</a:t>
             </a:r>
           </a:p>
         </p:txBody>
@@ -16362,7 +16362,7 @@
         </p:spPr>
         <p:txBody>
           <a:bodyPr wrap="none" lIns="0" rIns="0" tIns="0" bIns="0">
-            <a:spAutoFit/>
+            <a:noAutofit/>
           </a:bodyPr>
           <a:lstStyle/>
           <a:p>
@@ -16373,7 +16373,7 @@
                 </a:solidFill>
                 <a:latin typeface="Calibri"/>
               </a:rPr>
-              <a:t>500×. This week's lab no longer uses a cast specimen — casting </a:t>
+              <a:t>corrosion behavior, then research HV for both and log them — this</a:t>
             </a:r>
           </a:p>
         </p:txBody>
@@ -16396,7 +16396,7 @@
         </p:spPr>
         <p:txBody>
           <a:bodyPr wrap="none" lIns="0" rIns="0" tIns="0" bIns="0">
-            <a:spAutoFit/>
+            <a:noAutofit/>
           </a:bodyPr>
           <a:lstStyle/>
           <a:p>
@@ -16407,7 +16407,7 @@
                 </a:solidFill>
                 <a:latin typeface="Calibri"/>
               </a:rPr>
-              <a:t>fundamentals remain in today's lecture.</a:t>
+              <a:t>week restarts the Hardness Log begun in Module 6.</a:t>
             </a:r>
           </a:p>
         </p:txBody>
@@ -16464,7 +16464,7 @@
         </p:spPr>
         <p:txBody>
           <a:bodyPr wrap="none" lIns="0" rIns="0" tIns="0" bIns="0">
-            <a:spAutoFit/>
+            <a:noAutofit/>
           </a:bodyPr>
           <a:lstStyle/>
           <a:p>
@@ -16475,7 +16475,7 @@
                 </a:solidFill>
                 <a:latin typeface="Calibri"/>
               </a:rPr>
-              <a:t>1  Observe — complete feature table</a:t>
+              <a:t>1  Research — record data &amp; sources</a:t>
             </a:r>
           </a:p>
         </p:txBody>
@@ -16498,7 +16498,7 @@
         </p:spPr>
         <p:txBody>
           <a:bodyPr wrap="none" lIns="0" rIns="0" tIns="0" bIns="0">
-            <a:spAutoFit/>
+            <a:noAutofit/>
           </a:bodyPr>
           <a:lstStyle/>
           <a:p>
@@ -16509,7 +16509,7 @@
                 </a:solidFill>
                 <a:latin typeface="Calibri"/>
               </a:rPr>
-              <a:t>2  Sketch — label magnification &amp; specimen</a:t>
+              <a:t>2  Answer — short-answer questions</a:t>
             </a:r>
           </a:p>
         </p:txBody>
@@ -16532,7 +16532,7 @@
         </p:spPr>
         <p:txBody>
           <a:bodyPr wrap="none" lIns="0" rIns="0" tIns="0" bIns="0">
-            <a:spAutoFit/>
+            <a:noAutofit/>
           </a:bodyPr>
           <a:lstStyle/>
           <a:p>
@@ -16543,7 +16543,7 @@
                 </a:solidFill>
                 <a:latin typeface="Calibri"/>
               </a:rPr>
-              <a:t>3  Answer — 4 short questions</a:t>
+              <a:t>3  Apply — critical-thinking &amp; equations</a:t>
             </a:r>
           </a:p>
         </p:txBody>
@@ -16566,7 +16566,7 @@
         </p:spPr>
         <p:txBody>
           <a:bodyPr wrap="none" lIns="0" rIns="0" tIns="0" bIns="0">
-            <a:spAutoFit/>
+            <a:noAutofit/>
           </a:bodyPr>
           <a:lstStyle/>
           <a:p>
@@ -16577,7 +16577,7 @@
                 </a:solidFill>
                 <a:latin typeface="Calibri"/>
               </a:rPr>
-              <a:t>Specimens to Check Out</a:t>
+              <a:t>Alloys of Record</a:t>
             </a:r>
           </a:p>
         </p:txBody>
@@ -16600,7 +16600,7 @@
         </p:spPr>
         <p:txBody>
           <a:bodyPr wrap="none" lIns="0" rIns="0" tIns="0" bIns="0">
-            <a:spAutoFit/>
+            <a:noAutofit/>
           </a:bodyPr>
           <a:lstStyle/>
           <a:p>
@@ -16611,7 +16611,7 @@
                 </a:solidFill>
                 <a:latin typeface="Calibri"/>
               </a:rPr>
-              <a:t>· Specimens G, J — 6061-T6 &amp; 2024-T3 aluminum</a:t>
+              <a:t>· Alloys G, J — 6061-T6 &amp; 2024-T3 aluminum</a:t>
             </a:r>
           </a:p>
         </p:txBody>
@@ -16634,7 +16634,7 @@
         </p:spPr>
         <p:txBody>
           <a:bodyPr wrap="none" lIns="0" rIns="0" tIns="0" bIns="0">
-            <a:spAutoFit/>
+            <a:noAutofit/>
           </a:bodyPr>
           <a:lstStyle/>
           <a:p>
@@ -16645,7 +16645,7 @@
                 </a:solidFill>
                 <a:latin typeface="Calibri"/>
               </a:rPr>
-              <a:t>How to check out the kit:</a:t>
+              <a:t>How to Complete This Module:</a:t>
             </a:r>
           </a:p>
         </p:txBody>
@@ -16668,7 +16668,7 @@
         </p:spPr>
         <p:txBody>
           <a:bodyPr wrap="none" lIns="0" rIns="0" tIns="0" bIns="0">
-            <a:spAutoFit/>
+            <a:noAutofit/>
           </a:bodyPr>
           <a:lstStyle/>
           <a:p>
@@ -16679,7 +16679,7 @@
                 </a:solidFill>
                 <a:latin typeface="Calibri"/>
               </a:rPr>
-              <a:t>1  See instructor after class today</a:t>
+              <a:t>1  Research the alloy(s) using credible sources</a:t>
             </a:r>
           </a:p>
         </p:txBody>
@@ -16702,7 +16702,7 @@
         </p:spPr>
         <p:txBody>
           <a:bodyPr wrap="none" lIns="0" rIns="0" tIns="0" bIns="0">
-            <a:spAutoFit/>
+            <a:noAutofit/>
           </a:bodyPr>
           <a:lstStyle/>
           <a:p>
@@ -16713,7 +16713,7 @@
                 </a:solidFill>
                 <a:latin typeface="Calibri"/>
               </a:rPr>
-              <a:t>2  Sign out the specimen tray</a:t>
+              <a:t>2  Record data with a source citation</a:t>
             </a:r>
           </a:p>
         </p:txBody>
@@ -16736,7 +16736,7 @@
         </p:spPr>
         <p:txBody>
           <a:bodyPr wrap="none" lIns="0" rIns="0" tIns="0" bIns="0">
-            <a:spAutoFit/>
+            <a:noAutofit/>
           </a:bodyPr>
           <a:lstStyle/>
           <a:p>
@@ -16747,7 +16747,7 @@
                 </a:solidFill>
                 <a:latin typeface="Calibri"/>
               </a:rPr>
-              <a:t>3  Use the EXAMET-5 at your convenience</a:t>
+              <a:t>3  Answer the short-answer questions</a:t>
             </a:r>
           </a:p>
         </p:txBody>
@@ -16770,7 +16770,7 @@
         </p:spPr>
         <p:txBody>
           <a:bodyPr wrap="none" lIns="0" rIns="0" tIns="0" bIns="0">
-            <a:spAutoFit/>
+            <a:noAutofit/>
           </a:bodyPr>
           <a:lstStyle/>
           <a:p>
@@ -16781,7 +16781,7 @@
                 </a:solidFill>
                 <a:latin typeface="Calibri"/>
               </a:rPr>
-              <a:t>4  Return kit before leaving class</a:t>
+              <a:t>4  Answer the critical-thinking questions</a:t>
             </a:r>
           </a:p>
         </p:txBody>
@@ -16804,7 +16804,7 @@
         </p:spPr>
         <p:txBody>
           <a:bodyPr wrap="none" lIns="0" rIns="0" tIns="0" bIns="0">
-            <a:spAutoFit/>
+            <a:noAutofit/>
           </a:bodyPr>
           <a:lstStyle/>
           <a:p>
@@ -16815,7 +16815,7 @@
                 </a:solidFill>
                 <a:latin typeface="Calibri"/>
               </a:rPr>
-              <a:t>5  Submit completed module with your portfolio</a:t>
+              <a:t>5  Keep the module with your portfolio</a:t>
             </a:r>
           </a:p>
         </p:txBody>

</xml_diff>